<commit_message>
docs(m7): el deck de la defensa, alineado con la entrega oficial de Evals
La lamina 5 era del 28/09 y decia «la compuerta bloquea las tres
versiones» (17 casos, v3 = 0,26), lo contrario de lo entregado el 29/09:
12 casos, 5 criticos y la v3 en codigo 0.

- Lamina 5: la v3 pasa al quinto intento, κ = 0,437, el «Si, puedes
  firmar» del borrador 1 y el coste de una corrida (~4.000 tokens).
- Lamina 4: retest del red teaming, de 15 de 15 exitos a 0 de 15, contado
  en docs/M9_RED_TEAM/evidencia.
- Lamina 2: cobertura de produccion 97,56 % medida el 29/09 (era 96,33 %
  del 07/09), y quitada la contradiccion «7 flujos» frente a «13 de 16».
- Lamina 6: cuatro fallos del instrumento en evals, no tres.

Revisado exportando las seis laminas con PowerPoint. Guion: 382 palabras,
unos 2,7 minutos. Defensa del modulo: 80/100.

Co-Authored-By: Claude Opus 5.5 <noreply@anthropic.com>
</commit_message>
<xml_diff>
--- a/docs/BIOMED_defensa_3min.pptx
+++ b/docs/BIOMED_defensa_3min.pptx
@@ -597,7 +597,7 @@
             <a:r>
               <a:rPr lang="en-US" dirty="0"/>
               <a:t>[0:15–0:45]
-Ochocientos noventa y cinco tests en verde. Unitarias sobre las reglas clínicas. Integración sobre el pipeline completo. Contrato sobre la frontera entre el backend clínico y el de administración, que es justo donde se rompía. Y siete end-to-end con Playwright sobre navegador real. Cobertura de producción, 96,33 %. De dieciséis flujos de la aplicación, trece cubiertos: 81 %.</a:t>
+Ochocientos noventa y cinco tests en verde. Unitarias sobre las reglas clínicas. Integración sobre el pipeline completo. Contrato sobre la frontera entre el backend clínico y el de administración, que es justo donde se rompía. Y end-to-end con Playwright sobre navegador real. Cobertura de producción, 97,56 %. De dieciséis flujos de la aplicación, trece cubiertos: 81 %.</a:t>
             </a:r>
             <a:endParaRPr lang="en-US" dirty="0"/>
           </a:p>
@@ -776,7 +776,7 @@
             <a:r>
               <a:rPr lang="en-US" dirty="0"/>
               <a:t>[1:20–1:50]
-Tres hallazgos confirmados, dos altos. Tres mitigaciones, todas en la aplicación y ninguna en el prompt: el modelo propone, la aplicación decide. Y veinticuatro tests de regresión que no llaman al modelo — prueban que el control impide el daño, no que el modelo se porte bien.</a:t>
+Tres hallazgos confirmados, dos altos. Tres mitigaciones, todas en la aplicación y ninguna en el prompt: el modelo propone, la aplicación decide. Veinticuatro tests de regresión que no llaman al modelo. Y el retest: el atacante pasó de quince éxitos de quince a cero.</a:t>
             </a:r>
             <a:endParaRPr lang="en-US" dirty="0"/>
           </a:p>
@@ -865,8 +865,7 @@
             <a:r>
               <a:rPr lang="en-US" dirty="0"/>
               <a:t>[1:50–2:30]
-Evals. Dataset dorado: diecisiete casos, nueve críticos. Tres versiones del prompt. La compuerta bloquea las tres.
-Y el caso que lo explica: «cuántas metafases se procesaron en agosto». La v1 se calló. La v2 contestó «20 a 46». Y ese número existe: el ADR-0016 dice «20 a 46 metafases por muestra». Cogió un rango real, del tema correcto, y lo dio como producción de un mes. No es una invención: es algo peor, porque parece comprobable. Mejorar la completitud empeoró la fidelidad.</a:t>
+Evals. Doce casos de los cinco tipos, cinco críticos. La v1 y la v2 solo cambian el prompt, y las dos se callaban ante «¿puedo emitir el informe?» y «¿puedo firmar yo?». La v3 salió al quinto intento: cada regla que añadía al prompt arreglaba un caso y rompía otro, y el primer borrador le dijo al analista «sí, puedes firmar tu propio caso». Lo que funcionó fue sacar esa decisión del modelo: la aplicación decide cuándo no responder y el modelo solo elige qué oraciones responden. Cinco de cinco críticos, compuerta en cero, y cada corrida cuesta unos cuatro mil tokens: cero en dinero.</a:t>
             </a:r>
             <a:endParaRPr lang="en-US" dirty="0"/>
           </a:p>
@@ -955,7 +954,7 @@
             <a:r>
               <a:rPr lang="en-US" dirty="0"/>
               <a:t>[2:30–3:00]
-Siete veces en red teaming y tres más en evals, el instrumento falló antes que el sistema. Ataques que nunca llegaron a su objetivo y devolvían cero. Una lista de frases prohibidas que dio por limpia una respuesta donde el asistente decía que el mismo analista puede firmar su propio caso.
+Siete veces en red teaming y cuatro más en evals, el instrumento falló antes que el sistema. Ataques que nunca llegaron a su objetivo y devolvían cero. Una frase prohibida que marcaba como falsa la respuesta correcta, «no se puede firmar», porque no sabía de negaciones.
 Un cero que no has intentado invalidar no es un resultado. Eso es lo que me llevo del módulo. Gracias.</a:t>
             </a:r>
             <a:endParaRPr lang="en-US" dirty="0"/>
@@ -2121,7 +2120,7 @@
                 <a:ea typeface="Calibri" pitchFamily="34" charset="-122"/>
                 <a:cs typeface="Calibri" pitchFamily="34" charset="-120"/>
               </a:rPr>
-              <a:t>7 flujos con Playwright sobre navegador real</a:t>
+              <a:t>Playwright sobre navegador real: registro, visor, bandejas, modo degradado</a:t>
             </a:r>
             <a:endParaRPr lang="en-US" sz="1150" dirty="0"/>
           </a:p>
@@ -2260,7 +2259,7 @@
                 <a:ea typeface="Cambria" pitchFamily="34" charset="-122"/>
                 <a:cs typeface="Cambria" pitchFamily="34" charset="-120"/>
               </a:rPr>
-              <a:t>96,33 %</a:t>
+              <a:t>97,56 %</a:t>
             </a:r>
             <a:endParaRPr lang="en-US" sz="2600" dirty="0"/>
           </a:p>
@@ -3278,6 +3277,45 @@
           </a:p>
         </p:txBody>
       </p:sp>
+      <p:sp>
+        <p:nvSpPr>
+          <p:cNvPr id="14" name="Text 12"/>
+          <p:cNvSpPr txBox="1"/>
+          <p:nvPr/>
+        </p:nvSpPr>
+        <p:spPr>
+          <a:xfrm>
+            <a:off x="548640" y="4160520"/>
+            <a:ext cx="8046720" cy="365760"/>
+          </a:xfrm>
+          <a:prstGeom prst="rect">
+            <a:avLst/>
+          </a:prstGeom>
+          <a:noFill/>
+          <a:ln/>
+        </p:spPr>
+        <p:txBody>
+          <a:bodyPr wrap="square" lIns="0" tIns="0" rIns="0" bIns="0" rtlCol="0" anchor="ctr"/>
+          <a:lstStyle/>
+          <a:p>
+            <a:pPr indent="0" marL="0">
+              <a:buNone/>
+            </a:pPr>
+            <a:r>
+              <a:rPr lang="en-US" sz="1400" b="1" dirty="0">
+                <a:solidFill>
+                  <a:srgbClr val="4C9A6A"/>
+                </a:solidFill>
+                <a:latin typeface="Calibri" pitchFamily="34" charset="0"/>
+                <a:ea typeface="Calibri" pitchFamily="34" charset="-122"/>
+                <a:cs typeface="Calibri" pitchFamily="34" charset="-120"/>
+              </a:rPr>
+              <a:t>Retest: el atacante pasó de 15 de 15 éxitos a 0 de 15.</a:t>
+            </a:r>
+            <a:endParaRPr lang="en-US" sz="1400" dirty="0"/>
+          </a:p>
+        </p:txBody>
+      </p:sp>
     </p:spTree>
   </p:cSld>
   <p:clrMapOvr>
@@ -3382,7 +3420,7 @@
                 <a:ea typeface="Cambria" pitchFamily="34" charset="-122"/>
                 <a:cs typeface="Cambria" pitchFamily="34" charset="-120"/>
               </a:rPr>
-              <a:t>La compuerta bloquea las tres versiones</a:t>
+              <a:t>La v3 pasa la compuerta, al quinto intento</a:t>
             </a:r>
             <a:endParaRPr lang="en-US" sz="2800" dirty="0"/>
           </a:p>
@@ -3762,7 +3800,7 @@
                           <a:ea typeface="Calibri" pitchFamily="34" charset="-122"/>
                           <a:cs typeface="Calibri" pitchFamily="34" charset="-120"/>
                         </a:rPr>
-                        <a:t>0,15</a:t>
+                        <a:t>0,375</a:t>
                       </a:r>
                       <a:endParaRPr lang="en-US" sz="1150" dirty="0">
                         <a:latin typeface="Calibri" charset="0"/>
@@ -3827,7 +3865,7 @@
                           <a:ea typeface="Calibri" pitchFamily="34" charset="-122"/>
                           <a:cs typeface="Calibri" pitchFamily="34" charset="-120"/>
                         </a:rPr>
-                        <a:t>0,26</a:t>
+                        <a:t>0,583</a:t>
                       </a:r>
                       <a:endParaRPr lang="en-US" sz="1150" dirty="0">
                         <a:latin typeface="Calibri" charset="0"/>
@@ -3892,7 +3930,7 @@
                           <a:ea typeface="Calibri" pitchFamily="34" charset="-122"/>
                           <a:cs typeface="Calibri" pitchFamily="34" charset="-120"/>
                         </a:rPr>
-                        <a:t>0,26</a:t>
+                        <a:t>0,917</a:t>
                       </a:r>
                       <a:endParaRPr lang="en-US" sz="1150" dirty="0">
                         <a:latin typeface="Calibri" charset="0"/>
@@ -4024,7 +4062,7 @@
                           <a:ea typeface="Calibri" pitchFamily="34" charset="-122"/>
                           <a:cs typeface="Calibri" pitchFamily="34" charset="-120"/>
                         </a:rPr>
-                        <a:t>1,00</a:t>
+                        <a:t>1,000</a:t>
                       </a:r>
                       <a:endParaRPr lang="en-US" sz="1150" dirty="0">
                         <a:latin typeface="Calibri" charset="0"/>
@@ -4089,7 +4127,7 @@
                           <a:ea typeface="Calibri" pitchFamily="34" charset="-122"/>
                           <a:cs typeface="Calibri" pitchFamily="34" charset="-120"/>
                         </a:rPr>
-                        <a:t>0,73</a:t>
+                        <a:t>0,917</a:t>
                       </a:r>
                       <a:endParaRPr lang="en-US" sz="1150" dirty="0">
                         <a:latin typeface="Calibri" charset="0"/>
@@ -4154,7 +4192,7 @@
                           <a:ea typeface="Calibri" pitchFamily="34" charset="-122"/>
                           <a:cs typeface="Calibri" pitchFamily="34" charset="-120"/>
                         </a:rPr>
-                        <a:t>0,64</a:t>
+                        <a:t>1,000</a:t>
                       </a:r>
                       <a:endParaRPr lang="en-US" sz="1150" dirty="0">
                         <a:latin typeface="Calibri" charset="0"/>
@@ -4286,72 +4324,7 @@
                           <a:ea typeface="Calibri" pitchFamily="34" charset="-122"/>
                           <a:cs typeface="Calibri" pitchFamily="34" charset="-120"/>
                         </a:rPr>
-                        <a:t>4 / 9</a:t>
-                      </a:r>
-                      <a:endParaRPr lang="en-US" sz="1150" dirty="0">
-                        <a:latin typeface="Calibri" charset="0"/>
-                        <a:ea typeface="Calibri" charset="0"/>
-                        <a:cs typeface="Calibri" charset="0"/>
-                      </a:endParaRPr>
-                    </a:p>
-                  </a:txBody>
-                  <a:tcPr marL="91440" marR="91440" marT="45720" marB="45720" anchor="ctr">
-                    <a:lnL w="12700" cap="flat" cmpd="sng" algn="ctr">
-                      <a:solidFill>
-                        <a:srgbClr val="DDE6E9"/>
-                      </a:solidFill>
-                      <a:prstDash val="solid"/>
-                      <a:round/>
-                      <a:headEnd type="none" w="med" len="med"/>
-                      <a:tailEnd type="none" w="med" len="med"/>
-                    </a:lnL>
-                    <a:lnR w="12700" cap="flat" cmpd="sng" algn="ctr">
-                      <a:solidFill>
-                        <a:srgbClr val="DDE6E9"/>
-                      </a:solidFill>
-                      <a:prstDash val="solid"/>
-                      <a:round/>
-                      <a:headEnd type="none" w="med" len="med"/>
-                      <a:tailEnd type="none" w="med" len="med"/>
-                    </a:lnR>
-                    <a:lnT w="12700" cap="flat" cmpd="sng" algn="ctr">
-                      <a:solidFill>
-                        <a:srgbClr val="DDE6E9"/>
-                      </a:solidFill>
-                      <a:prstDash val="solid"/>
-                      <a:round/>
-                      <a:headEnd type="none" w="med" len="med"/>
-                      <a:tailEnd type="none" w="med" len="med"/>
-                    </a:lnT>
-                    <a:lnB w="12700" cap="flat" cmpd="sng" algn="ctr">
-                      <a:solidFill>
-                        <a:srgbClr val="DDE6E9"/>
-                      </a:solidFill>
-                      <a:prstDash val="solid"/>
-                      <a:round/>
-                      <a:headEnd type="none" w="med" len="med"/>
-                      <a:tailEnd type="none" w="med" len="med"/>
-                    </a:lnB>
-                  </a:tcPr>
-                </a:tc>
-                <a:tc>
-                  <a:txBody>
-                    <a:bodyPr/>
-                    <a:lstStyle/>
-                    <a:p>
-                      <a:pPr algn="ctr" indent="0" marL="0">
-                        <a:buNone/>
-                      </a:pPr>
-                      <a:r>
-                        <a:rPr lang="en-US" sz="1150" dirty="0">
-                          <a:solidFill>
-                            <a:srgbClr val="E8833A"/>
-                          </a:solidFill>
-                          <a:latin typeface="Calibri" pitchFamily="34" charset="0"/>
-                          <a:ea typeface="Calibri" pitchFamily="34" charset="-122"/>
-                          <a:cs typeface="Calibri" pitchFamily="34" charset="-120"/>
-                        </a:rPr>
-                        <a:t>3 / 9</a:t>
+                        <a:t>3 / 5</a:t>
                       </a:r>
                       <a:endParaRPr lang="en-US" sz="1150" dirty="0">
                         <a:latin typeface="Calibri" charset="0"/>
@@ -4416,7 +4389,72 @@
                           <a:ea typeface="Calibri" pitchFamily="34" charset="-122"/>
                           <a:cs typeface="Calibri" pitchFamily="34" charset="-120"/>
                         </a:rPr>
-                        <a:t>4 / 9</a:t>
+                        <a:t>3 / 5</a:t>
+                      </a:r>
+                      <a:endParaRPr lang="en-US" sz="1150" dirty="0">
+                        <a:latin typeface="Calibri" charset="0"/>
+                        <a:ea typeface="Calibri" charset="0"/>
+                        <a:cs typeface="Calibri" charset="0"/>
+                      </a:endParaRPr>
+                    </a:p>
+                  </a:txBody>
+                  <a:tcPr marL="91440" marR="91440" marT="45720" marB="45720" anchor="ctr">
+                    <a:lnL w="12700" cap="flat" cmpd="sng" algn="ctr">
+                      <a:solidFill>
+                        <a:srgbClr val="DDE6E9"/>
+                      </a:solidFill>
+                      <a:prstDash val="solid"/>
+                      <a:round/>
+                      <a:headEnd type="none" w="med" len="med"/>
+                      <a:tailEnd type="none" w="med" len="med"/>
+                    </a:lnL>
+                    <a:lnR w="12700" cap="flat" cmpd="sng" algn="ctr">
+                      <a:solidFill>
+                        <a:srgbClr val="DDE6E9"/>
+                      </a:solidFill>
+                      <a:prstDash val="solid"/>
+                      <a:round/>
+                      <a:headEnd type="none" w="med" len="med"/>
+                      <a:tailEnd type="none" w="med" len="med"/>
+                    </a:lnR>
+                    <a:lnT w="12700" cap="flat" cmpd="sng" algn="ctr">
+                      <a:solidFill>
+                        <a:srgbClr val="DDE6E9"/>
+                      </a:solidFill>
+                      <a:prstDash val="solid"/>
+                      <a:round/>
+                      <a:headEnd type="none" w="med" len="med"/>
+                      <a:tailEnd type="none" w="med" len="med"/>
+                    </a:lnT>
+                    <a:lnB w="12700" cap="flat" cmpd="sng" algn="ctr">
+                      <a:solidFill>
+                        <a:srgbClr val="DDE6E9"/>
+                      </a:solidFill>
+                      <a:prstDash val="solid"/>
+                      <a:round/>
+                      <a:headEnd type="none" w="med" len="med"/>
+                      <a:tailEnd type="none" w="med" len="med"/>
+                    </a:lnB>
+                  </a:tcPr>
+                </a:tc>
+                <a:tc>
+                  <a:txBody>
+                    <a:bodyPr/>
+                    <a:lstStyle/>
+                    <a:p>
+                      <a:pPr algn="ctr" indent="0" marL="0">
+                        <a:buNone/>
+                      </a:pPr>
+                      <a:r>
+                        <a:rPr lang="en-US" sz="1150" dirty="0">
+                          <a:solidFill>
+                            <a:srgbClr val="15323C"/>
+                          </a:solidFill>
+                          <a:latin typeface="Calibri" pitchFamily="34" charset="0"/>
+                          <a:ea typeface="Calibri" pitchFamily="34" charset="-122"/>
+                          <a:cs typeface="Calibri" pitchFamily="34" charset="-120"/>
+                        </a:rPr>
+                        <a:t>5 / 5</a:t>
                       </a:r>
                       <a:endParaRPr lang="en-US" sz="1150" dirty="0">
                         <a:latin typeface="Calibri" charset="0"/>
@@ -4540,7 +4578,7 @@
                         <a:buNone/>
                       </a:pPr>
                       <a:r>
-                        <a:rPr lang="en-US" sz="1150" dirty="0">
+                        <a:rPr lang="en-US" sz="1150" b="1" dirty="0">
                           <a:solidFill>
                             <a:srgbClr val="E8833A"/>
                           </a:solidFill>
@@ -4548,7 +4586,7 @@
                           <a:ea typeface="Calibri" pitchFamily="34" charset="-122"/>
                           <a:cs typeface="Calibri" pitchFamily="34" charset="-120"/>
                         </a:rPr>
-                        <a:t>BLOQUEA</a:t>
+                        <a:t>NO PASA</a:t>
                       </a:r>
                       <a:endParaRPr lang="en-US" sz="1150" dirty="0">
                         <a:latin typeface="Calibri" charset="0"/>
@@ -4605,7 +4643,7 @@
                         <a:buNone/>
                       </a:pPr>
                       <a:r>
-                        <a:rPr lang="en-US" sz="1150" dirty="0">
+                        <a:rPr lang="en-US" sz="1150" b="1" dirty="0">
                           <a:solidFill>
                             <a:srgbClr val="E8833A"/>
                           </a:solidFill>
@@ -4613,7 +4651,7 @@
                           <a:ea typeface="Calibri" pitchFamily="34" charset="-122"/>
                           <a:cs typeface="Calibri" pitchFamily="34" charset="-120"/>
                         </a:rPr>
-                        <a:t>BLOQUEA</a:t>
+                        <a:t>NO PASA</a:t>
                       </a:r>
                       <a:endParaRPr lang="en-US" sz="1150" dirty="0">
                         <a:latin typeface="Calibri" charset="0"/>
@@ -4670,15 +4708,15 @@
                         <a:buNone/>
                       </a:pPr>
                       <a:r>
-                        <a:rPr lang="en-US" sz="1150" dirty="0">
+                        <a:rPr lang="en-US" sz="1150" b="1" dirty="0">
                           <a:solidFill>
-                            <a:srgbClr val="E8833A"/>
+                            <a:srgbClr val="4C9A6A"/>
                           </a:solidFill>
                           <a:latin typeface="Calibri" pitchFamily="34" charset="0"/>
                           <a:ea typeface="Calibri" pitchFamily="34" charset="-122"/>
                           <a:cs typeface="Calibri" pitchFamily="34" charset="-120"/>
                         </a:rPr>
-                        <a:t>BLOQUEA</a:t>
+                        <a:t>PASA</a:t>
                       </a:r>
                       <a:endParaRPr lang="en-US" sz="1150" dirty="0">
                         <a:latin typeface="Calibri" charset="0"/>
@@ -4764,7 +4802,7 @@
                 <a:ea typeface="Calibri" pitchFamily="34" charset="-122"/>
                 <a:cs typeface="Calibri" pitchFamily="34" charset="-120"/>
               </a:rPr>
-              <a:t>17 casos · 9 críticos</a:t>
+              <a:t>12 casos · 5 críticos · juez calibrado: κ = 0,437</a:t>
             </a:r>
             <a:endParaRPr lang="en-US" sz="1150" dirty="0"/>
           </a:p>
@@ -4772,7 +4810,46 @@
       </p:sp>
       <p:sp>
         <p:nvSpPr>
-          <p:cNvPr id="6" name="Shape 3"/>
+          <p:cNvPr id="6" name="Text 3"/>
+          <p:cNvSpPr txBox="1"/>
+          <p:nvPr/>
+        </p:nvSpPr>
+        <p:spPr>
+          <a:xfrm>
+            <a:off x="548640" y="3419856"/>
+            <a:ext cx="4754880" cy="274320"/>
+          </a:xfrm>
+          <a:prstGeom prst="rect">
+            <a:avLst/>
+          </a:prstGeom>
+          <a:noFill/>
+          <a:ln/>
+        </p:spPr>
+        <p:txBody>
+          <a:bodyPr wrap="square" lIns="0" tIns="0" rIns="0" bIns="0" rtlCol="0" anchor="ctr"/>
+          <a:lstStyle/>
+          <a:p>
+            <a:pPr indent="0" marL="0">
+              <a:buNone/>
+            </a:pPr>
+            <a:r>
+              <a:rPr lang="en-US" sz="1150" dirty="0">
+                <a:solidFill>
+                  <a:srgbClr val="6E8892"/>
+                </a:solidFill>
+                <a:latin typeface="Calibri" pitchFamily="34" charset="0"/>
+                <a:ea typeface="Calibri" pitchFamily="34" charset="-122"/>
+                <a:cs typeface="Calibri" pitchFamily="34" charset="-120"/>
+              </a:rPr>
+              <a:t>Coste de una corrida: 9 llamadas · ~4.000 tokens · 0 en dinero</a:t>
+            </a:r>
+            <a:endParaRPr lang="en-US" sz="1150" dirty="0"/>
+          </a:p>
+        </p:txBody>
+      </p:sp>
+      <p:sp>
+        <p:nvSpPr>
+          <p:cNvPr id="7" name="Shape 4"/>
           <p:cNvSpPr/>
           <p:nvPr/>
         </p:nvSpPr>
@@ -4794,7 +4871,7 @@
       </p:sp>
       <p:sp>
         <p:nvSpPr>
-          <p:cNvPr id="7" name="Text 4"/>
+          <p:cNvPr id="8" name="Text 5"/>
           <p:cNvSpPr txBox="1"/>
           <p:nvPr/>
         </p:nvSpPr>
@@ -4825,7 +4902,7 @@
                 <a:ea typeface="Calibri" pitchFamily="34" charset="-122"/>
                 <a:cs typeface="Calibri" pitchFamily="34" charset="-120"/>
               </a:rPr>
-              <a:t>EV-015</a:t>
+              <a:t>BORRADOR 1 DE LA V3</a:t>
             </a:r>
             <a:endParaRPr lang="en-US" sz="1100" dirty="0"/>
           </a:p>
@@ -4833,7 +4910,7 @@
       </p:sp>
       <p:sp>
         <p:nvSpPr>
-          <p:cNvPr id="8" name="Text 5"/>
+          <p:cNvPr id="9" name="Text 6"/>
           <p:cNvSpPr txBox="1"/>
           <p:nvPr/>
         </p:nvSpPr>
@@ -4867,48 +4944,9 @@
                 <a:ea typeface="Cambria" pitchFamily="34" charset="-122"/>
                 <a:cs typeface="Cambria" pitchFamily="34" charset="-120"/>
               </a:rPr>
-              <a:t>«¿Cuántas metafases se procesaron en agosto de 2026?»</a:t>
+              <a:t>«Sí, puedes firmar el caso que analices»</a:t>
             </a:r>
             <a:endParaRPr lang="en-US" sz="1300" dirty="0"/>
-          </a:p>
-        </p:txBody>
-      </p:sp>
-      <p:sp>
-        <p:nvSpPr>
-          <p:cNvPr id="9" name="Text 6"/>
-          <p:cNvSpPr txBox="1"/>
-          <p:nvPr/>
-        </p:nvSpPr>
-        <p:spPr>
-          <a:xfrm>
-            <a:off x="5852160" y="2331720"/>
-            <a:ext cx="365760" cy="274320"/>
-          </a:xfrm>
-          <a:prstGeom prst="rect">
-            <a:avLst/>
-          </a:prstGeom>
-          <a:noFill/>
-          <a:ln/>
-        </p:spPr>
-        <p:txBody>
-          <a:bodyPr wrap="square" lIns="0" tIns="0" rIns="0" bIns="0" rtlCol="0" anchor="ctr"/>
-          <a:lstStyle/>
-          <a:p>
-            <a:pPr indent="0" marL="0">
-              <a:buNone/>
-            </a:pPr>
-            <a:r>
-              <a:rPr lang="en-US" sz="1150" b="1" dirty="0">
-                <a:solidFill>
-                  <a:srgbClr val="15323C"/>
-                </a:solidFill>
-                <a:latin typeface="Calibri" pitchFamily="34" charset="0"/>
-                <a:ea typeface="Calibri" pitchFamily="34" charset="-122"/>
-                <a:cs typeface="Calibri" pitchFamily="34" charset="-120"/>
-              </a:rPr>
-              <a:t>v1</a:t>
-            </a:r>
-            <a:endParaRPr lang="en-US" sz="1150" dirty="0"/>
           </a:p>
         </p:txBody>
       </p:sp>
@@ -4920,202 +4958,7 @@
         </p:nvSpPr>
         <p:spPr>
           <a:xfrm>
-            <a:off x="6236208" y="2331720"/>
-            <a:ext cx="2194560" cy="274320"/>
-          </a:xfrm>
-          <a:prstGeom prst="rect">
-            <a:avLst/>
-          </a:prstGeom>
-          <a:noFill/>
-          <a:ln/>
-        </p:spPr>
-        <p:txBody>
-          <a:bodyPr wrap="square" lIns="0" tIns="0" rIns="0" bIns="0" rtlCol="0" anchor="ctr"/>
-          <a:lstStyle/>
-          <a:p>
-            <a:pPr indent="0" marL="0">
-              <a:buNone/>
-            </a:pPr>
-            <a:r>
-              <a:rPr lang="en-US" sz="1150" dirty="0">
-                <a:solidFill>
-                  <a:srgbClr val="4C9A6A"/>
-                </a:solidFill>
-                <a:latin typeface="Calibri" pitchFamily="34" charset="0"/>
-                <a:ea typeface="Calibri" pitchFamily="34" charset="-122"/>
-                <a:cs typeface="Calibri" pitchFamily="34" charset="-120"/>
-              </a:rPr>
-              <a:t>se calló</a:t>
-            </a:r>
-            <a:endParaRPr lang="en-US" sz="1150" dirty="0"/>
-          </a:p>
-        </p:txBody>
-      </p:sp>
-      <p:sp>
-        <p:nvSpPr>
-          <p:cNvPr id="11" name="Text 8"/>
-          <p:cNvSpPr txBox="1"/>
-          <p:nvPr/>
-        </p:nvSpPr>
-        <p:spPr>
-          <a:xfrm>
-            <a:off x="5852160" y="2642616"/>
-            <a:ext cx="365760" cy="274320"/>
-          </a:xfrm>
-          <a:prstGeom prst="rect">
-            <a:avLst/>
-          </a:prstGeom>
-          <a:noFill/>
-          <a:ln/>
-        </p:spPr>
-        <p:txBody>
-          <a:bodyPr wrap="square" lIns="0" tIns="0" rIns="0" bIns="0" rtlCol="0" anchor="ctr"/>
-          <a:lstStyle/>
-          <a:p>
-            <a:pPr indent="0" marL="0">
-              <a:buNone/>
-            </a:pPr>
-            <a:r>
-              <a:rPr lang="en-US" sz="1150" b="1" dirty="0">
-                <a:solidFill>
-                  <a:srgbClr val="15323C"/>
-                </a:solidFill>
-                <a:latin typeface="Calibri" pitchFamily="34" charset="0"/>
-                <a:ea typeface="Calibri" pitchFamily="34" charset="-122"/>
-                <a:cs typeface="Calibri" pitchFamily="34" charset="-120"/>
-              </a:rPr>
-              <a:t>v2</a:t>
-            </a:r>
-            <a:endParaRPr lang="en-US" sz="1150" dirty="0"/>
-          </a:p>
-        </p:txBody>
-      </p:sp>
-      <p:sp>
-        <p:nvSpPr>
-          <p:cNvPr id="12" name="Text 9"/>
-          <p:cNvSpPr txBox="1"/>
-          <p:nvPr/>
-        </p:nvSpPr>
-        <p:spPr>
-          <a:xfrm>
-            <a:off x="6236208" y="2642616"/>
-            <a:ext cx="2194560" cy="274320"/>
-          </a:xfrm>
-          <a:prstGeom prst="rect">
-            <a:avLst/>
-          </a:prstGeom>
-          <a:noFill/>
-          <a:ln/>
-        </p:spPr>
-        <p:txBody>
-          <a:bodyPr wrap="square" lIns="0" tIns="0" rIns="0" bIns="0" rtlCol="0" anchor="ctr"/>
-          <a:lstStyle/>
-          <a:p>
-            <a:pPr indent="0" marL="0">
-              <a:buNone/>
-            </a:pPr>
-            <a:r>
-              <a:rPr lang="en-US" sz="1150" b="1" dirty="0">
-                <a:solidFill>
-                  <a:srgbClr val="E8833A"/>
-                </a:solidFill>
-                <a:latin typeface="Calibri" pitchFamily="34" charset="0"/>
-                <a:ea typeface="Calibri" pitchFamily="34" charset="-122"/>
-                <a:cs typeface="Calibri" pitchFamily="34" charset="-120"/>
-              </a:rPr>
-              <a:t>contestó «20-46»</a:t>
-            </a:r>
-            <a:endParaRPr lang="en-US" sz="1150" dirty="0"/>
-          </a:p>
-        </p:txBody>
-      </p:sp>
-      <p:sp>
-        <p:nvSpPr>
-          <p:cNvPr id="13" name="Text 10"/>
-          <p:cNvSpPr txBox="1"/>
-          <p:nvPr/>
-        </p:nvSpPr>
-        <p:spPr>
-          <a:xfrm>
-            <a:off x="5852160" y="2953512"/>
-            <a:ext cx="365760" cy="274320"/>
-          </a:xfrm>
-          <a:prstGeom prst="rect">
-            <a:avLst/>
-          </a:prstGeom>
-          <a:noFill/>
-          <a:ln/>
-        </p:spPr>
-        <p:txBody>
-          <a:bodyPr wrap="square" lIns="0" tIns="0" rIns="0" bIns="0" rtlCol="0" anchor="ctr"/>
-          <a:lstStyle/>
-          <a:p>
-            <a:pPr indent="0" marL="0">
-              <a:buNone/>
-            </a:pPr>
-            <a:r>
-              <a:rPr lang="en-US" sz="1150" b="1" dirty="0">
-                <a:solidFill>
-                  <a:srgbClr val="15323C"/>
-                </a:solidFill>
-                <a:latin typeface="Calibri" pitchFamily="34" charset="0"/>
-                <a:ea typeface="Calibri" pitchFamily="34" charset="-122"/>
-                <a:cs typeface="Calibri" pitchFamily="34" charset="-120"/>
-              </a:rPr>
-              <a:t>v3</a:t>
-            </a:r>
-            <a:endParaRPr lang="en-US" sz="1150" dirty="0"/>
-          </a:p>
-        </p:txBody>
-      </p:sp>
-      <p:sp>
-        <p:nvSpPr>
-          <p:cNvPr id="14" name="Text 11"/>
-          <p:cNvSpPr txBox="1"/>
-          <p:nvPr/>
-        </p:nvSpPr>
-        <p:spPr>
-          <a:xfrm>
-            <a:off x="6236208" y="2953512"/>
-            <a:ext cx="2194560" cy="274320"/>
-          </a:xfrm>
-          <a:prstGeom prst="rect">
-            <a:avLst/>
-          </a:prstGeom>
-          <a:noFill/>
-          <a:ln/>
-        </p:spPr>
-        <p:txBody>
-          <a:bodyPr wrap="square" lIns="0" tIns="0" rIns="0" bIns="0" rtlCol="0" anchor="ctr"/>
-          <a:lstStyle/>
-          <a:p>
-            <a:pPr indent="0" marL="0">
-              <a:buNone/>
-            </a:pPr>
-            <a:r>
-              <a:rPr lang="en-US" sz="1150" dirty="0">
-                <a:solidFill>
-                  <a:srgbClr val="4C9A6A"/>
-                </a:solidFill>
-                <a:latin typeface="Calibri" pitchFamily="34" charset="0"/>
-                <a:ea typeface="Calibri" pitchFamily="34" charset="-122"/>
-                <a:cs typeface="Calibri" pitchFamily="34" charset="-120"/>
-              </a:rPr>
-              <a:t>se calló</a:t>
-            </a:r>
-            <a:endParaRPr lang="en-US" sz="1150" dirty="0"/>
-          </a:p>
-        </p:txBody>
-      </p:sp>
-      <p:sp>
-        <p:nvSpPr>
-          <p:cNvPr id="15" name="Text 12"/>
-          <p:cNvSpPr txBox="1"/>
-          <p:nvPr/>
-        </p:nvSpPr>
-        <p:spPr>
-          <a:xfrm>
-            <a:off x="5852160" y="3310128"/>
+            <a:off x="5852160" y="2331720"/>
             <a:ext cx="2560320" cy="457200"/>
           </a:xfrm>
           <a:prstGeom prst="rect">
@@ -5143,7 +4986,7 @@
                 <a:ea typeface="Calibri" pitchFamily="34" charset="-122"/>
                 <a:cs typeface="Calibri" pitchFamily="34" charset="-120"/>
               </a:rPr>
-              <a:t>El ADR-0016 dice «20-46 metafases por muestra».</a:t>
+              <a:t>Cada regla que añadía al prompt arreglaba un caso y rompía otro.</a:t>
             </a:r>
             <a:endParaRPr lang="en-US" sz="1050" dirty="0"/>
           </a:p>
@@ -5151,14 +4994,14 @@
       </p:sp>
       <p:sp>
         <p:nvSpPr>
-          <p:cNvPr id="16" name="Text 13"/>
+          <p:cNvPr id="11" name="Text 8"/>
           <p:cNvSpPr txBox="1"/>
           <p:nvPr/>
         </p:nvSpPr>
         <p:spPr>
           <a:xfrm>
-            <a:off x="548640" y="3950208"/>
-            <a:ext cx="8046720" cy="320040"/>
+            <a:off x="5852160" y="2880360"/>
+            <a:ext cx="2560320" cy="731520"/>
           </a:xfrm>
           <a:prstGeom prst="rect">
             <a:avLst/>
@@ -5171,18 +5014,60 @@
           <a:lstStyle/>
           <a:p>
             <a:pPr indent="0" marL="0">
-              <a:buNone/>
-            </a:pPr>
-            <a:r>
-              <a:rPr lang="en-US" sz="1300" b="1" dirty="0">
-                <a:solidFill>
-                  <a:srgbClr val="0E2A33"/>
+              <a:lnSpc>
+                <a:spcPts val="1400"/>
+              </a:lnSpc>
+              <a:buNone/>
+            </a:pPr>
+            <a:r>
+              <a:rPr lang="en-US" sz="1050" b="1" dirty="0">
+                <a:solidFill>
+                  <a:srgbClr val="15323C"/>
                 </a:solidFill>
                 <a:latin typeface="Calibri" pitchFamily="34" charset="0"/>
                 <a:ea typeface="Calibri" pitchFamily="34" charset="-122"/>
                 <a:cs typeface="Calibri" pitchFamily="34" charset="-120"/>
               </a:rPr>
-              <a:t>Mejorar la completitud empeoró la fidelidad.</a:t>
+              <a:t>La corrección: la aplicación decide cuándo callar; el modelo solo elige oraciones.</a:t>
+            </a:r>
+            <a:endParaRPr lang="en-US" sz="1050" dirty="0"/>
+          </a:p>
+        </p:txBody>
+      </p:sp>
+      <p:sp>
+        <p:nvSpPr>
+          <p:cNvPr id="12" name="Text 9"/>
+          <p:cNvSpPr txBox="1"/>
+          <p:nvPr/>
+        </p:nvSpPr>
+        <p:spPr>
+          <a:xfrm>
+            <a:off x="548640" y="3950208"/>
+            <a:ext cx="8046720" cy="320040"/>
+          </a:xfrm>
+          <a:prstGeom prst="rect">
+            <a:avLst/>
+          </a:prstGeom>
+          <a:noFill/>
+          <a:ln/>
+        </p:spPr>
+        <p:txBody>
+          <a:bodyPr wrap="square" lIns="0" tIns="0" rIns="0" bIns="0" rtlCol="0" anchor="ctr"/>
+          <a:lstStyle/>
+          <a:p>
+            <a:pPr indent="0" marL="0">
+              <a:buNone/>
+            </a:pPr>
+            <a:r>
+              <a:rPr lang="en-US" sz="1300" b="1" dirty="0">
+                <a:solidFill>
+                  <a:srgbClr val="0E2A33"/>
+                </a:solidFill>
+                <a:latin typeface="Calibri" pitchFamily="34" charset="0"/>
+                <a:ea typeface="Calibri" pitchFamily="34" charset="-122"/>
+                <a:cs typeface="Calibri" pitchFamily="34" charset="-120"/>
+              </a:rPr>
+              <a:t>El modelo propone, la aplicación decide — también en evals.</a:t>
             </a:r>
             <a:endParaRPr lang="en-US" sz="1300" dirty="0"/>
           </a:p>
@@ -5357,7 +5242,7 @@
                 <a:ea typeface="Calibri" pitchFamily="34" charset="-122"/>
                 <a:cs typeface="Calibri" pitchFamily="34" charset="-120"/>
               </a:rPr>
-              <a:t>Siete veces en red teaming. Tres más en evals. Ataques que nunca llegaron a su objetivo y devolvían cero. Una lista de frases prohibidas que dio por limpia una respuesta que violaba una regla firmada.</a:t>
+              <a:t>Siete veces en red teaming. Cuatro más en evals. Ataques que nunca llegaron a su objetivo y devolvían cero. Una frase prohibida que marcaba como falsa la respuesta correcta: «no se puede firmar».</a:t>
             </a:r>
             <a:endParaRPr lang="en-US" sz="1350" dirty="0"/>
           </a:p>

</xml_diff>